<commit_message>
Mise à jour de la fiche mémo en anglais
</commit_message>
<xml_diff>
--- a/pictures/Memos/memo-en.pptx
+++ b/pictures/Memos/memo-en.pptx
@@ -197,7 +197,7 @@
           <a:p>
             <a:fld id="{849D895D-661B-479D-A688-27E503324CF6}" type="datetimeFigureOut">
               <a:rPr lang="fr-FR" smtClean="0"/>
-              <a:t>27/04/2026</a:t>
+              <a:t>30/05/2026</a:t>
             </a:fld>
             <a:endParaRPr lang="fr-FR"/>
           </a:p>
@@ -679,7 +679,7 @@
           <a:p>
             <a:fld id="{017B969D-5DBB-4D98-A8ED-E39D79CDECF7}" type="datetimeFigureOut">
               <a:rPr lang="fr-FR" smtClean="0"/>
-              <a:t>27/04/2026</a:t>
+              <a:t>30/05/2026</a:t>
             </a:fld>
             <a:endParaRPr lang="fr-FR"/>
           </a:p>
@@ -849,7 +849,7 @@
           <a:p>
             <a:fld id="{017B969D-5DBB-4D98-A8ED-E39D79CDECF7}" type="datetimeFigureOut">
               <a:rPr lang="fr-FR" smtClean="0"/>
-              <a:t>27/04/2026</a:t>
+              <a:t>30/05/2026</a:t>
             </a:fld>
             <a:endParaRPr lang="fr-FR"/>
           </a:p>
@@ -1029,7 +1029,7 @@
           <a:p>
             <a:fld id="{017B969D-5DBB-4D98-A8ED-E39D79CDECF7}" type="datetimeFigureOut">
               <a:rPr lang="fr-FR" smtClean="0"/>
-              <a:t>27/04/2026</a:t>
+              <a:t>30/05/2026</a:t>
             </a:fld>
             <a:endParaRPr lang="fr-FR"/>
           </a:p>
@@ -1199,7 +1199,7 @@
           <a:p>
             <a:fld id="{017B969D-5DBB-4D98-A8ED-E39D79CDECF7}" type="datetimeFigureOut">
               <a:rPr lang="fr-FR" smtClean="0"/>
-              <a:t>27/04/2026</a:t>
+              <a:t>30/05/2026</a:t>
             </a:fld>
             <a:endParaRPr lang="fr-FR"/>
           </a:p>
@@ -1445,7 +1445,7 @@
           <a:p>
             <a:fld id="{017B969D-5DBB-4D98-A8ED-E39D79CDECF7}" type="datetimeFigureOut">
               <a:rPr lang="fr-FR" smtClean="0"/>
-              <a:t>27/04/2026</a:t>
+              <a:t>30/05/2026</a:t>
             </a:fld>
             <a:endParaRPr lang="fr-FR"/>
           </a:p>
@@ -1677,7 +1677,7 @@
           <a:p>
             <a:fld id="{017B969D-5DBB-4D98-A8ED-E39D79CDECF7}" type="datetimeFigureOut">
               <a:rPr lang="fr-FR" smtClean="0"/>
-              <a:t>27/04/2026</a:t>
+              <a:t>30/05/2026</a:t>
             </a:fld>
             <a:endParaRPr lang="fr-FR"/>
           </a:p>
@@ -2044,7 +2044,7 @@
           <a:p>
             <a:fld id="{017B969D-5DBB-4D98-A8ED-E39D79CDECF7}" type="datetimeFigureOut">
               <a:rPr lang="fr-FR" smtClean="0"/>
-              <a:t>27/04/2026</a:t>
+              <a:t>30/05/2026</a:t>
             </a:fld>
             <a:endParaRPr lang="fr-FR"/>
           </a:p>
@@ -2162,7 +2162,7 @@
           <a:p>
             <a:fld id="{017B969D-5DBB-4D98-A8ED-E39D79CDECF7}" type="datetimeFigureOut">
               <a:rPr lang="fr-FR" smtClean="0"/>
-              <a:t>27/04/2026</a:t>
+              <a:t>30/05/2026</a:t>
             </a:fld>
             <a:endParaRPr lang="fr-FR"/>
           </a:p>
@@ -2257,7 +2257,7 @@
           <a:p>
             <a:fld id="{017B969D-5DBB-4D98-A8ED-E39D79CDECF7}" type="datetimeFigureOut">
               <a:rPr lang="fr-FR" smtClean="0"/>
-              <a:t>27/04/2026</a:t>
+              <a:t>30/05/2026</a:t>
             </a:fld>
             <a:endParaRPr lang="fr-FR"/>
           </a:p>
@@ -2534,7 +2534,7 @@
           <a:p>
             <a:fld id="{017B969D-5DBB-4D98-A8ED-E39D79CDECF7}" type="datetimeFigureOut">
               <a:rPr lang="fr-FR" smtClean="0"/>
-              <a:t>27/04/2026</a:t>
+              <a:t>30/05/2026</a:t>
             </a:fld>
             <a:endParaRPr lang="fr-FR"/>
           </a:p>
@@ -2791,7 +2791,7 @@
           <a:p>
             <a:fld id="{017B969D-5DBB-4D98-A8ED-E39D79CDECF7}" type="datetimeFigureOut">
               <a:rPr lang="fr-FR" smtClean="0"/>
-              <a:t>27/04/2026</a:t>
+              <a:t>30/05/2026</a:t>
             </a:fld>
             <a:endParaRPr lang="fr-FR"/>
           </a:p>
@@ -3004,7 +3004,7 @@
           <a:p>
             <a:fld id="{017B969D-5DBB-4D98-A8ED-E39D79CDECF7}" type="datetimeFigureOut">
               <a:rPr lang="fr-FR" smtClean="0"/>
-              <a:t>27/04/2026</a:t>
+              <a:t>30/05/2026</a:t>
             </a:fld>
             <a:endParaRPr lang="fr-FR"/>
           </a:p>
@@ -3973,7 +3973,7 @@
             </a:r>
             <a:r>
               <a:rPr lang="en-US" sz="1117" noProof="0" dirty="0"/>
-              <a:t>Resolve Calamity</a:t>
+              <a:t>Resolve Evant</a:t>
             </a:r>
           </a:p>
         </p:txBody>
@@ -4214,7 +4214,7 @@
         <p:spPr>
           <a:xfrm>
             <a:off x="2625795" y="2366738"/>
-            <a:ext cx="1682065" cy="264240"/>
+            <a:ext cx="1717182" cy="264240"/>
           </a:xfrm>
           <a:prstGeom prst="rect">
             <a:avLst/>
@@ -4251,8 +4251,8 @@
         </p:nvSpPr>
         <p:spPr>
           <a:xfrm>
-            <a:off x="2621110" y="2721793"/>
-            <a:ext cx="1656369" cy="264240"/>
+            <a:off x="2638553" y="2678836"/>
+            <a:ext cx="1704424" cy="264240"/>
           </a:xfrm>
           <a:prstGeom prst="rect">
             <a:avLst/>
@@ -4289,8 +4289,8 @@
         </p:nvSpPr>
         <p:spPr>
           <a:xfrm>
-            <a:off x="2629545" y="3102529"/>
-            <a:ext cx="1682065" cy="264240"/>
+            <a:off x="2651311" y="2993259"/>
+            <a:ext cx="1691666" cy="264240"/>
           </a:xfrm>
           <a:prstGeom prst="rect">
             <a:avLst/>
@@ -4327,8 +4327,8 @@
         </p:nvSpPr>
         <p:spPr>
           <a:xfrm>
-            <a:off x="2620612" y="3461953"/>
-            <a:ext cx="1682065" cy="822667"/>
+            <a:off x="2651311" y="3752491"/>
+            <a:ext cx="1691666" cy="531420"/>
           </a:xfrm>
           <a:prstGeom prst="rect">
             <a:avLst/>
@@ -4386,7 +4386,7 @@
         </p:nvSpPr>
         <p:spPr>
           <a:xfrm>
-            <a:off x="725718" y="2371636"/>
+            <a:off x="700318" y="2371636"/>
             <a:ext cx="1691666" cy="1918423"/>
           </a:xfrm>
           <a:prstGeom prst="rect">
@@ -4437,7 +4437,7 @@
         </p:nvSpPr>
         <p:spPr>
           <a:xfrm>
-            <a:off x="832460" y="2664682"/>
+            <a:off x="807060" y="2664682"/>
             <a:ext cx="1463066" cy="285237"/>
           </a:xfrm>
           <a:prstGeom prst="rect">
@@ -4523,7 +4523,7 @@
         </p:nvSpPr>
         <p:spPr>
           <a:xfrm>
-            <a:off x="832460" y="3056814"/>
+            <a:off x="807060" y="3056814"/>
             <a:ext cx="1463066" cy="285237"/>
           </a:xfrm>
           <a:prstGeom prst="rect">
@@ -4566,7 +4566,7 @@
         </p:nvSpPr>
         <p:spPr>
           <a:xfrm>
-            <a:off x="832460" y="3474620"/>
+            <a:off x="807060" y="3474620"/>
             <a:ext cx="1463066" cy="285237"/>
           </a:xfrm>
           <a:prstGeom prst="rect">
@@ -4609,7 +4609,7 @@
         </p:nvSpPr>
         <p:spPr>
           <a:xfrm>
-            <a:off x="832460" y="3862357"/>
+            <a:off x="807060" y="3862357"/>
             <a:ext cx="1463066" cy="285237"/>
           </a:xfrm>
           <a:prstGeom prst="rect">
@@ -4652,8 +4652,8 @@
         </p:nvSpPr>
         <p:spPr>
           <a:xfrm>
-            <a:off x="2710674" y="3755128"/>
-            <a:ext cx="1512306" cy="435473"/>
+            <a:off x="2751518" y="3959730"/>
+            <a:ext cx="1538310" cy="219036"/>
           </a:xfrm>
           <a:prstGeom prst="rect">
             <a:avLst/>
@@ -4676,14 +4676,7 @@
             <a:pPr algn="ctr"/>
             <a:r>
               <a:rPr lang="en-US" sz="1117" noProof="0" dirty="0"/>
-              <a:t>Draw each card</a:t>
-            </a:r>
-            <a:br>
-              <a:rPr lang="en-US" sz="1117" noProof="0" dirty="0"/>
-            </a:br>
-            <a:r>
-              <a:rPr lang="en-US" sz="1117" noProof="0" dirty="0"/>
-              <a:t>one by one</a:t>
+              <a:t>Draw each card 1 by 1</a:t>
             </a:r>
           </a:p>
         </p:txBody>
@@ -4932,11 +4925,13 @@
         </p:nvCxnSpPr>
         <p:spPr>
           <a:xfrm flipV="1">
-            <a:off x="4222980" y="3527081"/>
-            <a:ext cx="757171" cy="445784"/>
-          </a:xfrm>
-          <a:prstGeom prst="straightConnector1">
-            <a:avLst/>
+            <a:off x="4289828" y="3527081"/>
+            <a:ext cx="690323" cy="542167"/>
+          </a:xfrm>
+          <a:prstGeom prst="bentConnector3">
+            <a:avLst>
+              <a:gd name="adj1" fmla="val 50000"/>
+            </a:avLst>
           </a:prstGeom>
           <a:ln>
             <a:prstDash val="sysDash"/>
@@ -5040,12 +5035,71 @@
           </a:extLst>
         </p:spPr>
       </p:pic>
+      <p:sp>
+        <p:nvSpPr>
+          <p:cNvPr id="16" name="ZoneTexte 15">
+            <a:extLst>
+              <a:ext uri="{FF2B5EF4-FFF2-40B4-BE49-F238E27FC236}">
+                <a16:creationId xmlns:a16="http://schemas.microsoft.com/office/drawing/2014/main" id="{ECE59A6C-C1F3-2506-2BEF-F4AEACDD1743}"/>
+              </a:ext>
+            </a:extLst>
+          </p:cNvPr>
+          <p:cNvSpPr txBox="1"/>
+          <p:nvPr/>
+        </p:nvSpPr>
+        <p:spPr>
+          <a:xfrm>
+            <a:off x="2651311" y="3340042"/>
+            <a:ext cx="1691666" cy="291259"/>
+          </a:xfrm>
+          <a:prstGeom prst="rect">
+            <a:avLst/>
+          </a:prstGeom>
+          <a:blipFill>
+            <a:blip r:embed="rId4">
+              <a:extLst>
+                <a:ext uri="{BEBA8EAE-BF5A-486C-A8C5-ECC9F3942E4B}">
+                  <a14:imgProps xmlns:a14="http://schemas.microsoft.com/office/drawing/2010/main">
+                    <a14:imgLayer r:embed="rId5">
+                      <a14:imgEffect>
+                        <a14:artisticWatercolorSponge/>
+                      </a14:imgEffect>
+                      <a14:imgEffect>
+                        <a14:brightnessContrast bright="40000" contrast="-40000"/>
+                      </a14:imgEffect>
+                    </a14:imgLayer>
+                  </a14:imgProps>
+                </a:ext>
+              </a:extLst>
+            </a:blip>
+            <a:tile tx="0" ty="0" sx="100000" sy="100000" flip="none" algn="tl"/>
+          </a:blipFill>
+          <a:ln w="6350">
+            <a:solidFill>
+              <a:schemeClr val="tx1"/>
+            </a:solidFill>
+          </a:ln>
+        </p:spPr>
+        <p:txBody>
+          <a:bodyPr wrap="square" rtlCol="0">
+            <a:noAutofit/>
+          </a:bodyPr>
+          <a:lstStyle/>
+          <a:p>
+            <a:pPr algn="ctr"/>
+            <a:r>
+              <a:rPr lang="en-US" sz="1117" noProof="0" dirty="0"/>
+              <a:t>Spy</a:t>
+            </a:r>
+          </a:p>
+        </p:txBody>
+      </p:sp>
       <p:pic>
         <p:nvPicPr>
-          <p:cNvPr id="20" name="Image 19">
+          <p:cNvPr id="30" name="Image 29">
             <a:extLst>
               <a:ext uri="{FF2B5EF4-FFF2-40B4-BE49-F238E27FC236}">
-                <a16:creationId xmlns:a16="http://schemas.microsoft.com/office/drawing/2014/main" id="{3E4D74DD-FFBB-3663-FF94-ED58319C8A50}"/>
+                <a16:creationId xmlns:a16="http://schemas.microsoft.com/office/drawing/2014/main" id="{29C9C883-A08C-1143-0123-132D70CFA9B9}"/>
               </a:ext>
             </a:extLst>
           </p:cNvPr>
@@ -5062,15 +5116,15 @@
               </a:ext>
             </a:extLst>
           </a:blip>
-          <a:srcRect l="37706" r="37747" b="25002"/>
+          <a:srcRect l="37488" r="37446" b="24600"/>
           <a:stretch>
             <a:fillRect/>
           </a:stretch>
         </p:blipFill>
         <p:spPr bwMode="auto">
           <a:xfrm>
-            <a:off x="2322963" y="8932403"/>
-            <a:ext cx="4145434" cy="1419897"/>
+            <a:off x="2287455" y="8827695"/>
+            <a:ext cx="4831468" cy="1627479"/>
           </a:xfrm>
           <a:prstGeom prst="rect">
             <a:avLst/>

</xml_diff>

<commit_message>
Peaufinage du PDF français
</commit_message>
<xml_diff>
--- a/pictures/Memos/memo-en.pptx
+++ b/pictures/Memos/memo-en.pptx
@@ -197,7 +197,7 @@
           <a:p>
             <a:fld id="{849D895D-661B-479D-A688-27E503324CF6}" type="datetimeFigureOut">
               <a:rPr lang="fr-FR" smtClean="0"/>
-              <a:t>30/05/2026</a:t>
+              <a:t>05/07/2026</a:t>
             </a:fld>
             <a:endParaRPr lang="fr-FR"/>
           </a:p>
@@ -679,7 +679,7 @@
           <a:p>
             <a:fld id="{017B969D-5DBB-4D98-A8ED-E39D79CDECF7}" type="datetimeFigureOut">
               <a:rPr lang="fr-FR" smtClean="0"/>
-              <a:t>30/05/2026</a:t>
+              <a:t>05/07/2026</a:t>
             </a:fld>
             <a:endParaRPr lang="fr-FR"/>
           </a:p>
@@ -849,7 +849,7 @@
           <a:p>
             <a:fld id="{017B969D-5DBB-4D98-A8ED-E39D79CDECF7}" type="datetimeFigureOut">
               <a:rPr lang="fr-FR" smtClean="0"/>
-              <a:t>30/05/2026</a:t>
+              <a:t>05/07/2026</a:t>
             </a:fld>
             <a:endParaRPr lang="fr-FR"/>
           </a:p>
@@ -1029,7 +1029,7 @@
           <a:p>
             <a:fld id="{017B969D-5DBB-4D98-A8ED-E39D79CDECF7}" type="datetimeFigureOut">
               <a:rPr lang="fr-FR" smtClean="0"/>
-              <a:t>30/05/2026</a:t>
+              <a:t>05/07/2026</a:t>
             </a:fld>
             <a:endParaRPr lang="fr-FR"/>
           </a:p>
@@ -1199,7 +1199,7 @@
           <a:p>
             <a:fld id="{017B969D-5DBB-4D98-A8ED-E39D79CDECF7}" type="datetimeFigureOut">
               <a:rPr lang="fr-FR" smtClean="0"/>
-              <a:t>30/05/2026</a:t>
+              <a:t>05/07/2026</a:t>
             </a:fld>
             <a:endParaRPr lang="fr-FR"/>
           </a:p>
@@ -1445,7 +1445,7 @@
           <a:p>
             <a:fld id="{017B969D-5DBB-4D98-A8ED-E39D79CDECF7}" type="datetimeFigureOut">
               <a:rPr lang="fr-FR" smtClean="0"/>
-              <a:t>30/05/2026</a:t>
+              <a:t>05/07/2026</a:t>
             </a:fld>
             <a:endParaRPr lang="fr-FR"/>
           </a:p>
@@ -1677,7 +1677,7 @@
           <a:p>
             <a:fld id="{017B969D-5DBB-4D98-A8ED-E39D79CDECF7}" type="datetimeFigureOut">
               <a:rPr lang="fr-FR" smtClean="0"/>
-              <a:t>30/05/2026</a:t>
+              <a:t>05/07/2026</a:t>
             </a:fld>
             <a:endParaRPr lang="fr-FR"/>
           </a:p>
@@ -2044,7 +2044,7 @@
           <a:p>
             <a:fld id="{017B969D-5DBB-4D98-A8ED-E39D79CDECF7}" type="datetimeFigureOut">
               <a:rPr lang="fr-FR" smtClean="0"/>
-              <a:t>30/05/2026</a:t>
+              <a:t>05/07/2026</a:t>
             </a:fld>
             <a:endParaRPr lang="fr-FR"/>
           </a:p>
@@ -2162,7 +2162,7 @@
           <a:p>
             <a:fld id="{017B969D-5DBB-4D98-A8ED-E39D79CDECF7}" type="datetimeFigureOut">
               <a:rPr lang="fr-FR" smtClean="0"/>
-              <a:t>30/05/2026</a:t>
+              <a:t>05/07/2026</a:t>
             </a:fld>
             <a:endParaRPr lang="fr-FR"/>
           </a:p>
@@ -2257,7 +2257,7 @@
           <a:p>
             <a:fld id="{017B969D-5DBB-4D98-A8ED-E39D79CDECF7}" type="datetimeFigureOut">
               <a:rPr lang="fr-FR" smtClean="0"/>
-              <a:t>30/05/2026</a:t>
+              <a:t>05/07/2026</a:t>
             </a:fld>
             <a:endParaRPr lang="fr-FR"/>
           </a:p>
@@ -2534,7 +2534,7 @@
           <a:p>
             <a:fld id="{017B969D-5DBB-4D98-A8ED-E39D79CDECF7}" type="datetimeFigureOut">
               <a:rPr lang="fr-FR" smtClean="0"/>
-              <a:t>30/05/2026</a:t>
+              <a:t>05/07/2026</a:t>
             </a:fld>
             <a:endParaRPr lang="fr-FR"/>
           </a:p>
@@ -2791,7 +2791,7 @@
           <a:p>
             <a:fld id="{017B969D-5DBB-4D98-A8ED-E39D79CDECF7}" type="datetimeFigureOut">
               <a:rPr lang="fr-FR" smtClean="0"/>
-              <a:t>30/05/2026</a:t>
+              <a:t>05/07/2026</a:t>
             </a:fld>
             <a:endParaRPr lang="fr-FR"/>
           </a:p>
@@ -3004,7 +3004,7 @@
           <a:p>
             <a:fld id="{017B969D-5DBB-4D98-A8ED-E39D79CDECF7}" type="datetimeFigureOut">
               <a:rPr lang="fr-FR" smtClean="0"/>
-              <a:t>30/05/2026</a:t>
+              <a:t>05/07/2026</a:t>
             </a:fld>
             <a:endParaRPr lang="fr-FR"/>
           </a:p>
@@ -3527,8 +3527,8 @@
         </p:nvSpPr>
         <p:spPr>
           <a:xfrm>
-            <a:off x="4810180" y="2184517"/>
-            <a:ext cx="2308744" cy="2355940"/>
+            <a:off x="4810180" y="4047077"/>
+            <a:ext cx="2308744" cy="496707"/>
           </a:xfrm>
           <a:prstGeom prst="rect">
             <a:avLst/>
@@ -3609,57 +3609,6 @@
       </p:sp>
       <p:sp>
         <p:nvSpPr>
-          <p:cNvPr id="216" name="ZoneTexte 215">
-            <a:extLst>
-              <a:ext uri="{FF2B5EF4-FFF2-40B4-BE49-F238E27FC236}">
-                <a16:creationId xmlns:a16="http://schemas.microsoft.com/office/drawing/2014/main" id="{A22F7A29-34AB-1622-248B-87B64EB60B36}"/>
-              </a:ext>
-            </a:extLst>
-          </p:cNvPr>
-          <p:cNvSpPr txBox="1"/>
-          <p:nvPr/>
-        </p:nvSpPr>
-        <p:spPr>
-          <a:xfrm>
-            <a:off x="4980151" y="2706773"/>
-            <a:ext cx="1915543" cy="1640615"/>
-          </a:xfrm>
-          <a:prstGeom prst="rect">
-            <a:avLst/>
-          </a:prstGeom>
-          <a:solidFill>
-            <a:schemeClr val="bg1">
-              <a:lumMod val="75000"/>
-            </a:schemeClr>
-          </a:solidFill>
-          <a:ln w="6350">
-            <a:noFill/>
-          </a:ln>
-        </p:spPr>
-        <p:txBody>
-          <a:bodyPr wrap="square" rtlCol="0">
-            <a:noAutofit/>
-          </a:bodyPr>
-          <a:lstStyle/>
-          <a:p>
-            <a:pPr algn="ctr"/>
-            <a:r>
-              <a:rPr lang="en-US" sz="1200" dirty="0"/>
-              <a:t>Draw each card</a:t>
-            </a:r>
-            <a:br>
-              <a:rPr lang="en-US" sz="1200" dirty="0"/>
-            </a:br>
-            <a:r>
-              <a:rPr lang="en-US" sz="1200" dirty="0"/>
-              <a:t>one by one</a:t>
-            </a:r>
-            <a:endParaRPr lang="en-US" sz="1117" noProof="0" dirty="0"/>
-          </a:p>
-        </p:txBody>
-      </p:sp>
-      <p:sp>
-        <p:nvSpPr>
           <p:cNvPr id="4" name="ZoneTexte 3">
             <a:extLst>
               <a:ext uri="{FF2B5EF4-FFF2-40B4-BE49-F238E27FC236}">
@@ -3871,109 +3820,6 @@
             <a:r>
               <a:rPr lang="en-US" sz="1117" noProof="0" dirty="0"/>
               <a:t>Update the score track</a:t>
-            </a:r>
-          </a:p>
-        </p:txBody>
-      </p:sp>
-      <p:sp>
-        <p:nvSpPr>
-          <p:cNvPr id="12" name="ZoneTexte 11">
-            <a:extLst>
-              <a:ext uri="{FF2B5EF4-FFF2-40B4-BE49-F238E27FC236}">
-                <a16:creationId xmlns:a16="http://schemas.microsoft.com/office/drawing/2014/main" id="{339C86B1-F9A8-AE14-9545-EEE77A7647BE}"/>
-              </a:ext>
-            </a:extLst>
-          </p:cNvPr>
-          <p:cNvSpPr txBox="1"/>
-          <p:nvPr/>
-        </p:nvSpPr>
-        <p:spPr>
-          <a:xfrm>
-            <a:off x="5115154" y="3196538"/>
-            <a:ext cx="1691262" cy="461665"/>
-          </a:xfrm>
-          <a:prstGeom prst="rect">
-            <a:avLst/>
-          </a:prstGeom>
-          <a:solidFill>
-            <a:schemeClr val="bg1"/>
-          </a:solidFill>
-        </p:spPr>
-        <p:txBody>
-          <a:bodyPr wrap="square" rtlCol="0">
-            <a:spAutoFit/>
-          </a:bodyPr>
-          <a:lstStyle/>
-          <a:p>
-            <a:pPr algn="ctr"/>
-            <a:r>
-              <a:rPr lang="en-US" sz="1200" dirty="0"/>
-              <a:t>Action card drawn </a:t>
-            </a:r>
-            <a:br>
-              <a:rPr lang="en-US" sz="1200" dirty="0"/>
-            </a:br>
-            <a:r>
-              <a:rPr lang="en-US" sz="1200" dirty="0">
-                <a:sym typeface="Wingdings" panose="05000000000000000000" pitchFamily="2" charset="2"/>
-              </a:rPr>
-              <a:t></a:t>
-            </a:r>
-            <a:r>
-              <a:rPr lang="en-US" sz="1200" dirty="0"/>
-              <a:t> Add to hand</a:t>
-            </a:r>
-            <a:endParaRPr lang="en-US" sz="1117" noProof="0" dirty="0"/>
-          </a:p>
-        </p:txBody>
-      </p:sp>
-      <p:sp>
-        <p:nvSpPr>
-          <p:cNvPr id="13" name="ZoneTexte 12">
-            <a:extLst>
-              <a:ext uri="{FF2B5EF4-FFF2-40B4-BE49-F238E27FC236}">
-                <a16:creationId xmlns:a16="http://schemas.microsoft.com/office/drawing/2014/main" id="{154A6FF8-9966-AAC6-8637-61073C9102C1}"/>
-              </a:ext>
-            </a:extLst>
-          </p:cNvPr>
-          <p:cNvSpPr txBox="1"/>
-          <p:nvPr/>
-        </p:nvSpPr>
-        <p:spPr>
-          <a:xfrm>
-            <a:off x="5103064" y="3768779"/>
-            <a:ext cx="1691262" cy="436145"/>
-          </a:xfrm>
-          <a:prstGeom prst="rect">
-            <a:avLst/>
-          </a:prstGeom>
-          <a:solidFill>
-            <a:schemeClr val="bg1"/>
-          </a:solidFill>
-        </p:spPr>
-        <p:txBody>
-          <a:bodyPr wrap="square" rtlCol="0">
-            <a:spAutoFit/>
-          </a:bodyPr>
-          <a:lstStyle/>
-          <a:p>
-            <a:pPr algn="ctr"/>
-            <a:r>
-              <a:rPr lang="en-US" sz="1117" noProof="0" dirty="0"/>
-              <a:t>Event card drawn</a:t>
-            </a:r>
-            <a:br>
-              <a:rPr lang="en-US" sz="1117" noProof="0" dirty="0"/>
-            </a:br>
-            <a:r>
-              <a:rPr lang="en-US" sz="1117" noProof="0" dirty="0">
-                <a:sym typeface="Wingdings" panose="05000000000000000000" pitchFamily="2" charset="2"/>
-              </a:rPr>
-              <a:t> </a:t>
-            </a:r>
-            <a:r>
-              <a:rPr lang="en-US" sz="1117" noProof="0" dirty="0"/>
-              <a:t>Resolve Event</a:t>
             </a:r>
           </a:p>
         </p:txBody>
@@ -4108,7 +3954,7 @@
             <a:pPr algn="ctr"/>
             <a:r>
               <a:rPr lang="en-US" sz="1117" noProof="0" dirty="0"/>
-              <a:t>Choose Action cards for a maximum total of 3 credits</a:t>
+              <a:t>Choose cards for a maximum amount of credits</a:t>
             </a:r>
           </a:p>
         </p:txBody>
@@ -4328,7 +4174,7 @@
         <p:spPr>
           <a:xfrm>
             <a:off x="2651311" y="3752491"/>
-            <a:ext cx="1691666" cy="531420"/>
+            <a:ext cx="1691666" cy="291259"/>
           </a:xfrm>
           <a:prstGeom prst="rect">
             <a:avLst/>
@@ -4485,7 +4331,7 @@
         <p:spPr>
           <a:xfrm>
             <a:off x="5960786" y="1935002"/>
-            <a:ext cx="3766" cy="249515"/>
+            <a:ext cx="3766" cy="2112075"/>
           </a:xfrm>
           <a:prstGeom prst="straightConnector1">
             <a:avLst/>
@@ -4634,49 +4480,6 @@
                 </a:solidFill>
               </a:rPr>
               <a:t>Concentrate Troops</a:t>
-            </a:r>
-          </a:p>
-        </p:txBody>
-      </p:sp>
-      <p:sp>
-        <p:nvSpPr>
-          <p:cNvPr id="151" name="ZoneTexte 150">
-            <a:extLst>
-              <a:ext uri="{FF2B5EF4-FFF2-40B4-BE49-F238E27FC236}">
-                <a16:creationId xmlns:a16="http://schemas.microsoft.com/office/drawing/2014/main" id="{398B0C1F-5543-7C34-1D5A-A56699A8CB59}"/>
-              </a:ext>
-            </a:extLst>
-          </p:cNvPr>
-          <p:cNvSpPr txBox="1"/>
-          <p:nvPr/>
-        </p:nvSpPr>
-        <p:spPr>
-          <a:xfrm>
-            <a:off x="2751518" y="3959730"/>
-            <a:ext cx="1538310" cy="219036"/>
-          </a:xfrm>
-          <a:prstGeom prst="rect">
-            <a:avLst/>
-          </a:prstGeom>
-          <a:solidFill>
-            <a:schemeClr val="bg1">
-              <a:lumMod val="75000"/>
-            </a:schemeClr>
-          </a:solidFill>
-          <a:ln w="6350">
-            <a:noFill/>
-          </a:ln>
-        </p:spPr>
-        <p:txBody>
-          <a:bodyPr wrap="square" rtlCol="0">
-            <a:noAutofit/>
-          </a:bodyPr>
-          <a:lstStyle/>
-          <a:p>
-            <a:pPr algn="ctr"/>
-            <a:r>
-              <a:rPr lang="en-US" sz="1117" noProof="0" dirty="0"/>
-              <a:t>Draw each card 1 by 1</a:t>
             </a:r>
           </a:p>
         </p:txBody>
@@ -4698,13 +4501,13 @@
           <p:nvPr/>
         </p:nvCxnSpPr>
         <p:spPr>
-          <a:xfrm rot="5400000" flipH="1" flipV="1">
-            <a:off x="4254890" y="2834123"/>
-            <a:ext cx="3327" cy="3415995"/>
+          <a:xfrm rot="16200000" flipH="1">
+            <a:off x="4256554" y="2835786"/>
+            <a:ext cx="12700" cy="3415995"/>
           </a:xfrm>
           <a:prstGeom prst="bentConnector3">
             <a:avLst>
-              <a:gd name="adj1" fmla="val -6871055"/>
+              <a:gd name="adj1" fmla="val 1800000"/>
             </a:avLst>
           </a:prstGeom>
           <a:ln>
@@ -4907,52 +4710,6 @@
           </a:xfrm>
         </p:grpSpPr>
       </p:grpSp>
-      <p:cxnSp>
-        <p:nvCxnSpPr>
-          <p:cNvPr id="2" name="Connecteur : en angle 97">
-            <a:extLst>
-              <a:ext uri="{FF2B5EF4-FFF2-40B4-BE49-F238E27FC236}">
-                <a16:creationId xmlns:a16="http://schemas.microsoft.com/office/drawing/2014/main" id="{E5D30D6B-D0E7-91D1-A62F-2BD99E1D2788}"/>
-              </a:ext>
-            </a:extLst>
-          </p:cNvPr>
-          <p:cNvCxnSpPr>
-            <a:cxnSpLocks/>
-            <a:stCxn id="151" idx="3"/>
-            <a:endCxn id="216" idx="1"/>
-          </p:cNvCxnSpPr>
-          <p:nvPr/>
-        </p:nvCxnSpPr>
-        <p:spPr>
-          <a:xfrm flipV="1">
-            <a:off x="4289828" y="3527081"/>
-            <a:ext cx="690323" cy="542167"/>
-          </a:xfrm>
-          <a:prstGeom prst="bentConnector3">
-            <a:avLst>
-              <a:gd name="adj1" fmla="val 50000"/>
-            </a:avLst>
-          </a:prstGeom>
-          <a:ln>
-            <a:prstDash val="sysDash"/>
-            <a:tailEnd type="triangle"/>
-          </a:ln>
-        </p:spPr>
-        <p:style>
-          <a:lnRef idx="2">
-            <a:schemeClr val="accent1"/>
-          </a:lnRef>
-          <a:fillRef idx="0">
-            <a:schemeClr val="accent1"/>
-          </a:fillRef>
-          <a:effectRef idx="1">
-            <a:schemeClr val="accent1"/>
-          </a:effectRef>
-          <a:fontRef idx="minor">
-            <a:schemeClr val="tx1"/>
-          </a:fontRef>
-        </p:style>
-      </p:cxnSp>
       <p:pic>
         <p:nvPicPr>
           <p:cNvPr id="38" name="Graphique 37" descr="Couronne avec un remplissage uni">

</xml_diff>